<commit_message>
fix typo in presentation
</commit_message>
<xml_diff>
--- a/clean-code.pptx
+++ b/clean-code.pptx
@@ -16858,7 +16858,11 @@
             </a:r>
             <a:r>
               <a:rPr lang="ru-RU" dirty="0" smtClean="0"/>
-              <a:t> контрольное число</a:t>
+              <a:t> </a:t>
+            </a:r>
+            <a:r>
+              <a:rPr lang="en-US" dirty="0" err="1"/>
+              <a:t>controldigit</a:t>
             </a:r>
             <a:endParaRPr lang="en-US" dirty="0"/>
           </a:p>
@@ -17046,7 +17050,11 @@
             </a:r>
             <a:r>
               <a:rPr lang="ru-RU" dirty="0" smtClean="0"/>
-              <a:t> контрольное число</a:t>
+              <a:t> </a:t>
+            </a:r>
+            <a:r>
+              <a:rPr lang="en-US" dirty="0" err="1"/>
+              <a:t>controldigit</a:t>
             </a:r>
             <a:endParaRPr lang="en-US" dirty="0"/>
           </a:p>
@@ -26518,7 +26526,11 @@
             </a:r>
             <a:r>
               <a:rPr lang="ru-RU" dirty="0" smtClean="0"/>
-              <a:t> контрольное число</a:t>
+              <a:t> </a:t>
+            </a:r>
+            <a:r>
+              <a:rPr lang="en-US" dirty="0" err="1"/>
+              <a:t>controldigit</a:t>
             </a:r>
             <a:endParaRPr lang="en-US" dirty="0"/>
           </a:p>
@@ -26705,7 +26717,11 @@
             </a:r>
             <a:r>
               <a:rPr lang="ru-RU" dirty="0" smtClean="0"/>
-              <a:t> контрольное число</a:t>
+              <a:t> </a:t>
+            </a:r>
+            <a:r>
+              <a:rPr lang="en-US" dirty="0" err="1"/>
+              <a:t>controldigit</a:t>
             </a:r>
             <a:endParaRPr lang="en-US" dirty="0"/>
           </a:p>
@@ -27503,7 +27519,11 @@
             </a:r>
             <a:r>
               <a:rPr lang="ru-RU" dirty="0" smtClean="0"/>
-              <a:t> контрольное число</a:t>
+              <a:t> </a:t>
+            </a:r>
+            <a:r>
+              <a:rPr lang="en-US" dirty="0" err="1"/>
+              <a:t>controldigit</a:t>
             </a:r>
             <a:endParaRPr lang="en-US" dirty="0"/>
           </a:p>
@@ -46892,7 +46912,11 @@
             </a:r>
             <a:r>
               <a:rPr lang="ru-RU" dirty="0" smtClean="0"/>
-              <a:t> контрольное число</a:t>
+              <a:t> </a:t>
+            </a:r>
+            <a:r>
+              <a:rPr lang="en-US" dirty="0" err="1"/>
+              <a:t>controldigit</a:t>
             </a:r>
             <a:endParaRPr lang="en-US" dirty="0"/>
           </a:p>
@@ -47592,7 +47616,11 @@
             </a:r>
             <a:r>
               <a:rPr lang="ru-RU" dirty="0" smtClean="0"/>
-              <a:t> контрольное число</a:t>
+              <a:t> </a:t>
+            </a:r>
+            <a:r>
+              <a:rPr lang="en-US" dirty="0" err="1"/>
+              <a:t>controldigit</a:t>
             </a:r>
             <a:endParaRPr lang="en-US" dirty="0"/>
           </a:p>
@@ -48213,7 +48241,11 @@
             </a:r>
             <a:r>
               <a:rPr lang="ru-RU" dirty="0" smtClean="0"/>
-              <a:t> контрольное число</a:t>
+              <a:t> </a:t>
+            </a:r>
+            <a:r>
+              <a:rPr lang="en-US" dirty="0" err="1"/>
+              <a:t>controldigit</a:t>
             </a:r>
             <a:endParaRPr lang="en-US" dirty="0"/>
           </a:p>

</xml_diff>